<commit_message>
Sync latest CLM microhack content: add C1 step screenshots + doc refresh
Mirror remaining delta from glejdis/microhack-aiagents@main on top of the
gpt-5.4-nano model switch:
- Add 9 Challenge 1 step screenshots wired into challenge-01.md slots
  (fork, Codespace, az login, azd up, portal RG, Foundry deployments, smoke).
- Refresh challenge-01.md, README, and marketing deck.

Co-authored-by: Copilot App <223556219+Copilot@users.noreply.github.com>
Copilot-Session: 56e340cf-1118-41ad-b0d0-8812f357f5f4
</commit_message>
<xml_diff>
--- a/03-Azure/01-04-AI/04_Agentic_Contract_Lifecycle_Management/docs/marketing/TechTalk_ContractMgmt_AgenticAI.pptx
+++ b/03-Azure/01-04-AI/04_Agentic_Contract_Lifecycle_Management/docs/marketing/TechTalk_ContractMgmt_AgenticAI.pptx
@@ -110,6 +110,227 @@
     </p:ext>
   </p:extLst>
 </p:presentation>
+</file>
+
+<file path=ppt/revisionInfo.xml><?xml version="1.0" encoding="utf-8"?>
+<p1510:revInfo xmlns:a="http://schemas.openxmlformats.org/drawingml/2006/main" xmlns:r="http://schemas.openxmlformats.org/officeDocument/2006/relationships" xmlns:p1510="http://schemas.microsoft.com/office/powerpoint/2015/10/main">
+  <p1510:revLst>
+    <p1510:client id="{AB8CF1AA-6DCA-459E-9B64-2959834C4AF0}" v="3" dt="2026-07-29T18:40:24.802"/>
+  </p1510:revLst>
+</p1510:revInfo>
+</file>
+
+<file path=ppt/changesInfos/changesInfo1.xml><?xml version="1.0" encoding="utf-8"?>
+<pc:chgInfo xmlns:a="http://schemas.openxmlformats.org/drawingml/2006/main" xmlns:r="http://schemas.openxmlformats.org/officeDocument/2006/relationships" xmlns:ac="http://schemas.microsoft.com/office/drawing/2013/main/command" xmlns:pc="http://schemas.microsoft.com/office/powerpoint/2013/main/command">
+  <pc:docChgLst>
+    <pc:chgData name="Glejdis Shkembi" userId="1c63e9c2-f066-4d08-a46c-6f3c67414dab" providerId="ADAL" clId="{D59F3545-C3AF-42EE-AFFA-D09C72A691CB}"/>
+    <pc:docChg chg="undo custSel modSld">
+      <pc:chgData name="Glejdis Shkembi" userId="1c63e9c2-f066-4d08-a46c-6f3c67414dab" providerId="ADAL" clId="{D59F3545-C3AF-42EE-AFFA-D09C72A691CB}" dt="2026-07-29T18:41:58.234" v="68" actId="14100"/>
+      <pc:docMkLst>
+        <pc:docMk/>
+      </pc:docMkLst>
+      <pc:sldChg chg="modSp mod">
+        <pc:chgData name="Glejdis Shkembi" userId="1c63e9c2-f066-4d08-a46c-6f3c67414dab" providerId="ADAL" clId="{D59F3545-C3AF-42EE-AFFA-D09C72A691CB}" dt="2026-07-29T18:41:58.234" v="68" actId="14100"/>
+        <pc:sldMkLst>
+          <pc:docMk/>
+          <pc:sldMk cId="0" sldId="256"/>
+        </pc:sldMkLst>
+        <pc:spChg chg="mod">
+          <ac:chgData name="Glejdis Shkembi" userId="1c63e9c2-f066-4d08-a46c-6f3c67414dab" providerId="ADAL" clId="{D59F3545-C3AF-42EE-AFFA-D09C72A691CB}" dt="2026-07-29T18:41:45.010" v="48" actId="14100"/>
+          <ac:spMkLst>
+            <pc:docMk/>
+            <pc:sldMk cId="0" sldId="256"/>
+            <ac:spMk id="8" creationId="{00000000-0000-0000-0000-000000000000}"/>
+          </ac:spMkLst>
+        </pc:spChg>
+        <pc:spChg chg="mod">
+          <ac:chgData name="Glejdis Shkembi" userId="1c63e9c2-f066-4d08-a46c-6f3c67414dab" providerId="ADAL" clId="{D59F3545-C3AF-42EE-AFFA-D09C72A691CB}" dt="2026-07-29T18:41:38.436" v="47" actId="1035"/>
+          <ac:spMkLst>
+            <pc:docMk/>
+            <pc:sldMk cId="0" sldId="256"/>
+            <ac:spMk id="11" creationId="{00000000-0000-0000-0000-000000000000}"/>
+          </ac:spMkLst>
+        </pc:spChg>
+        <pc:spChg chg="mod">
+          <ac:chgData name="Glejdis Shkembi" userId="1c63e9c2-f066-4d08-a46c-6f3c67414dab" providerId="ADAL" clId="{D59F3545-C3AF-42EE-AFFA-D09C72A691CB}" dt="2026-07-29T18:41:38.436" v="47" actId="1035"/>
+          <ac:spMkLst>
+            <pc:docMk/>
+            <pc:sldMk cId="0" sldId="256"/>
+            <ac:spMk id="12" creationId="{00000000-0000-0000-0000-000000000000}"/>
+          </ac:spMkLst>
+        </pc:spChg>
+        <pc:spChg chg="mod">
+          <ac:chgData name="Glejdis Shkembi" userId="1c63e9c2-f066-4d08-a46c-6f3c67414dab" providerId="ADAL" clId="{D59F3545-C3AF-42EE-AFFA-D09C72A691CB}" dt="2026-07-29T18:41:38.436" v="47" actId="1035"/>
+          <ac:spMkLst>
+            <pc:docMk/>
+            <pc:sldMk cId="0" sldId="256"/>
+            <ac:spMk id="13" creationId="{00000000-0000-0000-0000-000000000000}"/>
+          </ac:spMkLst>
+        </pc:spChg>
+        <pc:spChg chg="mod">
+          <ac:chgData name="Glejdis Shkembi" userId="1c63e9c2-f066-4d08-a46c-6f3c67414dab" providerId="ADAL" clId="{D59F3545-C3AF-42EE-AFFA-D09C72A691CB}" dt="2026-07-29T18:41:32.051" v="30" actId="14100"/>
+          <ac:spMkLst>
+            <pc:docMk/>
+            <pc:sldMk cId="0" sldId="256"/>
+            <ac:spMk id="14" creationId="{00000000-0000-0000-0000-000000000000}"/>
+          </ac:spMkLst>
+        </pc:spChg>
+        <pc:spChg chg="mod">
+          <ac:chgData name="Glejdis Shkembi" userId="1c63e9c2-f066-4d08-a46c-6f3c67414dab" providerId="ADAL" clId="{D59F3545-C3AF-42EE-AFFA-D09C72A691CB}" dt="2026-07-29T18:41:26.321" v="29" actId="1036"/>
+          <ac:spMkLst>
+            <pc:docMk/>
+            <pc:sldMk cId="0" sldId="256"/>
+            <ac:spMk id="17" creationId="{00000000-0000-0000-0000-000000000000}"/>
+          </ac:spMkLst>
+        </pc:spChg>
+        <pc:spChg chg="mod">
+          <ac:chgData name="Glejdis Shkembi" userId="1c63e9c2-f066-4d08-a46c-6f3c67414dab" providerId="ADAL" clId="{D59F3545-C3AF-42EE-AFFA-D09C72A691CB}" dt="2026-07-29T18:41:26.321" v="29" actId="1036"/>
+          <ac:spMkLst>
+            <pc:docMk/>
+            <pc:sldMk cId="0" sldId="256"/>
+            <ac:spMk id="18" creationId="{00000000-0000-0000-0000-000000000000}"/>
+          </ac:spMkLst>
+        </pc:spChg>
+        <pc:spChg chg="mod">
+          <ac:chgData name="Glejdis Shkembi" userId="1c63e9c2-f066-4d08-a46c-6f3c67414dab" providerId="ADAL" clId="{D59F3545-C3AF-42EE-AFFA-D09C72A691CB}" dt="2026-07-29T18:41:26.321" v="29" actId="1036"/>
+          <ac:spMkLst>
+            <pc:docMk/>
+            <pc:sldMk cId="0" sldId="256"/>
+            <ac:spMk id="20" creationId="{00000000-0000-0000-0000-000000000000}"/>
+          </ac:spMkLst>
+        </pc:spChg>
+        <pc:spChg chg="mod">
+          <ac:chgData name="Glejdis Shkembi" userId="1c63e9c2-f066-4d08-a46c-6f3c67414dab" providerId="ADAL" clId="{D59F3545-C3AF-42EE-AFFA-D09C72A691CB}" dt="2026-07-29T18:41:26.321" v="29" actId="1036"/>
+          <ac:spMkLst>
+            <pc:docMk/>
+            <pc:sldMk cId="0" sldId="256"/>
+            <ac:spMk id="21" creationId="{00000000-0000-0000-0000-000000000000}"/>
+          </ac:spMkLst>
+        </pc:spChg>
+        <pc:spChg chg="mod">
+          <ac:chgData name="Glejdis Shkembi" userId="1c63e9c2-f066-4d08-a46c-6f3c67414dab" providerId="ADAL" clId="{D59F3545-C3AF-42EE-AFFA-D09C72A691CB}" dt="2026-07-29T18:41:26.321" v="29" actId="1036"/>
+          <ac:spMkLst>
+            <pc:docMk/>
+            <pc:sldMk cId="0" sldId="256"/>
+            <ac:spMk id="22" creationId="{00000000-0000-0000-0000-000000000000}"/>
+          </ac:spMkLst>
+        </pc:spChg>
+        <pc:spChg chg="mod">
+          <ac:chgData name="Glejdis Shkembi" userId="1c63e9c2-f066-4d08-a46c-6f3c67414dab" providerId="ADAL" clId="{D59F3545-C3AF-42EE-AFFA-D09C72A691CB}" dt="2026-07-29T18:41:26.321" v="29" actId="1036"/>
+          <ac:spMkLst>
+            <pc:docMk/>
+            <pc:sldMk cId="0" sldId="256"/>
+            <ac:spMk id="23" creationId="{00000000-0000-0000-0000-000000000000}"/>
+          </ac:spMkLst>
+        </pc:spChg>
+        <pc:spChg chg="mod">
+          <ac:chgData name="Glejdis Shkembi" userId="1c63e9c2-f066-4d08-a46c-6f3c67414dab" providerId="ADAL" clId="{D59F3545-C3AF-42EE-AFFA-D09C72A691CB}" dt="2026-07-29T18:41:26.321" v="29" actId="1036"/>
+          <ac:spMkLst>
+            <pc:docMk/>
+            <pc:sldMk cId="0" sldId="256"/>
+            <ac:spMk id="26" creationId="{00000000-0000-0000-0000-000000000000}"/>
+          </ac:spMkLst>
+        </pc:spChg>
+        <pc:spChg chg="mod">
+          <ac:chgData name="Glejdis Shkembi" userId="1c63e9c2-f066-4d08-a46c-6f3c67414dab" providerId="ADAL" clId="{D59F3545-C3AF-42EE-AFFA-D09C72A691CB}" dt="2026-07-29T18:41:26.321" v="29" actId="1036"/>
+          <ac:spMkLst>
+            <pc:docMk/>
+            <pc:sldMk cId="0" sldId="256"/>
+            <ac:spMk id="27" creationId="{00000000-0000-0000-0000-000000000000}"/>
+          </ac:spMkLst>
+        </pc:spChg>
+        <pc:spChg chg="mod">
+          <ac:chgData name="Glejdis Shkembi" userId="1c63e9c2-f066-4d08-a46c-6f3c67414dab" providerId="ADAL" clId="{D59F3545-C3AF-42EE-AFFA-D09C72A691CB}" dt="2026-07-29T18:41:26.321" v="29" actId="1036"/>
+          <ac:spMkLst>
+            <pc:docMk/>
+            <pc:sldMk cId="0" sldId="256"/>
+            <ac:spMk id="29" creationId="{00000000-0000-0000-0000-000000000000}"/>
+          </ac:spMkLst>
+        </pc:spChg>
+        <pc:spChg chg="mod">
+          <ac:chgData name="Glejdis Shkembi" userId="1c63e9c2-f066-4d08-a46c-6f3c67414dab" providerId="ADAL" clId="{D59F3545-C3AF-42EE-AFFA-D09C72A691CB}" dt="2026-07-29T18:41:26.321" v="29" actId="1036"/>
+          <ac:spMkLst>
+            <pc:docMk/>
+            <pc:sldMk cId="0" sldId="256"/>
+            <ac:spMk id="30" creationId="{00000000-0000-0000-0000-000000000000}"/>
+          </ac:spMkLst>
+        </pc:spChg>
+        <pc:spChg chg="mod">
+          <ac:chgData name="Glejdis Shkembi" userId="1c63e9c2-f066-4d08-a46c-6f3c67414dab" providerId="ADAL" clId="{D59F3545-C3AF-42EE-AFFA-D09C72A691CB}" dt="2026-07-29T18:41:58.234" v="68" actId="14100"/>
+          <ac:spMkLst>
+            <pc:docMk/>
+            <pc:sldMk cId="0" sldId="256"/>
+            <ac:spMk id="37" creationId="{00000000-0000-0000-0000-000000000000}"/>
+          </ac:spMkLst>
+        </pc:spChg>
+        <pc:spChg chg="mod">
+          <ac:chgData name="Glejdis Shkembi" userId="1c63e9c2-f066-4d08-a46c-6f3c67414dab" providerId="ADAL" clId="{D59F3545-C3AF-42EE-AFFA-D09C72A691CB}" dt="2026-07-29T18:41:54.335" v="67" actId="1036"/>
+          <ac:spMkLst>
+            <pc:docMk/>
+            <pc:sldMk cId="0" sldId="256"/>
+            <ac:spMk id="40" creationId="{00000000-0000-0000-0000-000000000000}"/>
+          </ac:spMkLst>
+        </pc:spChg>
+        <pc:spChg chg="mod">
+          <ac:chgData name="Glejdis Shkembi" userId="1c63e9c2-f066-4d08-a46c-6f3c67414dab" providerId="ADAL" clId="{D59F3545-C3AF-42EE-AFFA-D09C72A691CB}" dt="2026-07-29T18:41:54.335" v="67" actId="1036"/>
+          <ac:spMkLst>
+            <pc:docMk/>
+            <pc:sldMk cId="0" sldId="256"/>
+            <ac:spMk id="41" creationId="{00000000-0000-0000-0000-000000000000}"/>
+          </ac:spMkLst>
+        </pc:spChg>
+        <pc:spChg chg="mod">
+          <ac:chgData name="Glejdis Shkembi" userId="1c63e9c2-f066-4d08-a46c-6f3c67414dab" providerId="ADAL" clId="{D59F3545-C3AF-42EE-AFFA-D09C72A691CB}" dt="2026-07-29T18:41:54.335" v="67" actId="1036"/>
+          <ac:spMkLst>
+            <pc:docMk/>
+            <pc:sldMk cId="0" sldId="256"/>
+            <ac:spMk id="44" creationId="{00000000-0000-0000-0000-000000000000}"/>
+          </ac:spMkLst>
+        </pc:spChg>
+        <pc:spChg chg="mod">
+          <ac:chgData name="Glejdis Shkembi" userId="1c63e9c2-f066-4d08-a46c-6f3c67414dab" providerId="ADAL" clId="{D59F3545-C3AF-42EE-AFFA-D09C72A691CB}" dt="2026-07-29T18:41:54.335" v="67" actId="1036"/>
+          <ac:spMkLst>
+            <pc:docMk/>
+            <pc:sldMk cId="0" sldId="256"/>
+            <ac:spMk id="45" creationId="{00000000-0000-0000-0000-000000000000}"/>
+          </ac:spMkLst>
+        </pc:spChg>
+        <pc:graphicFrameChg chg="mod">
+          <ac:chgData name="Glejdis Shkembi" userId="1c63e9c2-f066-4d08-a46c-6f3c67414dab" providerId="ADAL" clId="{D59F3545-C3AF-42EE-AFFA-D09C72A691CB}" dt="2026-07-29T18:41:54.335" v="67" actId="1036"/>
+          <ac:graphicFrameMkLst>
+            <pc:docMk/>
+            <pc:sldMk cId="0" sldId="256"/>
+            <ac:graphicFrameMk id="42" creationId="{00000000-0000-0000-0000-000000000000}"/>
+          </ac:graphicFrameMkLst>
+        </pc:graphicFrameChg>
+        <pc:picChg chg="mod">
+          <ac:chgData name="Glejdis Shkembi" userId="1c63e9c2-f066-4d08-a46c-6f3c67414dab" providerId="ADAL" clId="{D59F3545-C3AF-42EE-AFFA-D09C72A691CB}" dt="2026-07-29T18:41:38.436" v="47" actId="1035"/>
+          <ac:picMkLst>
+            <pc:docMk/>
+            <pc:sldMk cId="0" sldId="256"/>
+            <ac:picMk id="10" creationId="{00000000-0000-0000-0000-000000000000}"/>
+          </ac:picMkLst>
+        </pc:picChg>
+        <pc:picChg chg="mod">
+          <ac:chgData name="Glejdis Shkembi" userId="1c63e9c2-f066-4d08-a46c-6f3c67414dab" providerId="ADAL" clId="{D59F3545-C3AF-42EE-AFFA-D09C72A691CB}" dt="2026-07-29T18:41:54.335" v="67" actId="1036"/>
+          <ac:picMkLst>
+            <pc:docMk/>
+            <pc:sldMk cId="0" sldId="256"/>
+            <ac:picMk id="39" creationId="{00000000-0000-0000-0000-000000000000}"/>
+          </ac:picMkLst>
+        </pc:picChg>
+        <pc:picChg chg="mod">
+          <ac:chgData name="Glejdis Shkembi" userId="1c63e9c2-f066-4d08-a46c-6f3c67414dab" providerId="ADAL" clId="{D59F3545-C3AF-42EE-AFFA-D09C72A691CB}" dt="2026-07-29T18:41:54.335" v="67" actId="1036"/>
+          <ac:picMkLst>
+            <pc:docMk/>
+            <pc:sldMk cId="0" sldId="256"/>
+            <ac:picMk id="43" creationId="{00000000-0000-0000-0000-000000000000}"/>
+          </ac:picMkLst>
+        </pc:picChg>
+      </pc:sldChg>
+    </pc:docChg>
+  </pc:docChgLst>
+</pc:chgInfo>
 </file>
 
 <file path=ppt/notesMasters/notesMaster1.xml><?xml version="1.0" encoding="utf-8"?>
@@ -831,6 +1052,7 @@
                 <a:latin typeface="Segoe UI" pitchFamily="34" charset="0"/>
                 <a:ea typeface="Segoe UI" pitchFamily="34" charset="-122"/>
                 <a:cs typeface="Segoe UI" pitchFamily="34" charset="-120"/>
+                <a:hlinkClick r:id="rId5"/>
               </a:rPr>
               <a:t>HERE</a:t>
             </a:r>
@@ -853,6 +1075,7 @@
                 <a:latin typeface="Segoe UI" pitchFamily="34" charset="0"/>
                 <a:ea typeface="Segoe UI" pitchFamily="34" charset="-122"/>
                 <a:cs typeface="Segoe UI" pitchFamily="34" charset="-120"/>
+                <a:hlinkClick r:id="rId6"/>
               </a:rPr>
               <a:t>HERE</a:t>
             </a:r>
@@ -875,6 +1098,7 @@
                 <a:latin typeface="Segoe UI" pitchFamily="34" charset="0"/>
                 <a:ea typeface="Segoe UI" pitchFamily="34" charset="-122"/>
                 <a:cs typeface="Segoe UI" pitchFamily="34" charset="-120"/>
+                <a:hlinkClick r:id="rId7"/>
               </a:rPr>
               <a:t>HERE</a:t>
             </a:r>
@@ -954,7 +1178,7 @@
         <p:spPr>
           <a:xfrm>
             <a:off x="292608" y="1627632"/>
-            <a:ext cx="5650992" cy="1610868"/>
+            <a:ext cx="5650992" cy="1789378"/>
           </a:xfrm>
           <a:prstGeom prst="roundRect">
             <a:avLst>
@@ -1154,7 +1378,7 @@
         </p:blipFill>
         <p:spPr>
           <a:xfrm>
-            <a:off x="292608" y="3328960"/>
+            <a:off x="292608" y="3490330"/>
             <a:ext cx="5650992" cy="329184"/>
           </a:xfrm>
           <a:prstGeom prst="rect">
@@ -1170,7 +1394,7 @@
         </p:nvSpPr>
         <p:spPr>
           <a:xfrm>
-            <a:off x="420624" y="3328960"/>
+            <a:off x="420624" y="3490330"/>
             <a:ext cx="3108046" cy="329184"/>
           </a:xfrm>
           <a:prstGeom prst="rect">
@@ -1209,7 +1433,7 @@
         </p:nvSpPr>
         <p:spPr>
           <a:xfrm>
-            <a:off x="292608" y="3676432"/>
+            <a:off x="292608" y="3837802"/>
             <a:ext cx="5650992" cy="329184"/>
           </a:xfrm>
           <a:prstGeom prst="roundRect">
@@ -1250,7 +1474,7 @@
         </p:nvSpPr>
         <p:spPr>
           <a:xfrm>
-            <a:off x="438912" y="3676432"/>
+            <a:off x="438912" y="3837802"/>
             <a:ext cx="5358384" cy="329184"/>
           </a:xfrm>
           <a:prstGeom prst="rect">
@@ -1289,8 +1513,8 @@
         </p:nvSpPr>
         <p:spPr>
           <a:xfrm>
-            <a:off x="292608" y="4042192"/>
-            <a:ext cx="5650992" cy="2724912"/>
+            <a:off x="292608" y="4240306"/>
+            <a:ext cx="5650992" cy="2526798"/>
           </a:xfrm>
           <a:prstGeom prst="roundRect">
             <a:avLst>
@@ -1330,7 +1554,7 @@
         </p:nvSpPr>
         <p:spPr>
           <a:xfrm>
-            <a:off x="438912" y="4170208"/>
+            <a:off x="438912" y="4322613"/>
             <a:ext cx="5358384" cy="310896"/>
           </a:xfrm>
           <a:prstGeom prst="roundRect">
@@ -1359,7 +1583,7 @@
         </p:nvSpPr>
         <p:spPr>
           <a:xfrm>
-            <a:off x="438912" y="4170208"/>
+            <a:off x="438912" y="4322613"/>
             <a:ext cx="5358384" cy="310896"/>
           </a:xfrm>
           <a:prstGeom prst="rect">
@@ -1409,7 +1633,7 @@
         </p:nvSpPr>
         <p:spPr>
           <a:xfrm>
-            <a:off x="1289304" y="4481104"/>
+            <a:off x="1289304" y="4633509"/>
             <a:ext cx="0" cy="201168"/>
           </a:xfrm>
           <a:prstGeom prst="line">
@@ -1439,7 +1663,7 @@
         </p:nvSpPr>
         <p:spPr>
           <a:xfrm>
-            <a:off x="438912" y="4682272"/>
+            <a:off x="438912" y="4834677"/>
             <a:ext cx="1700784" cy="859536"/>
           </a:xfrm>
           <a:prstGeom prst="roundRect">
@@ -1468,7 +1692,7 @@
         </p:nvSpPr>
         <p:spPr>
           <a:xfrm>
-            <a:off x="475488" y="4682272"/>
+            <a:off x="475488" y="4834677"/>
             <a:ext cx="1627632" cy="859536"/>
           </a:xfrm>
           <a:prstGeom prst="rect">
@@ -1541,7 +1765,7 @@
         </p:nvSpPr>
         <p:spPr>
           <a:xfrm>
-            <a:off x="3118104" y="4481104"/>
+            <a:off x="3118104" y="4633509"/>
             <a:ext cx="0" cy="201168"/>
           </a:xfrm>
           <a:prstGeom prst="line">
@@ -1571,7 +1795,7 @@
         </p:nvSpPr>
         <p:spPr>
           <a:xfrm>
-            <a:off x="2267712" y="4682272"/>
+            <a:off x="2267712" y="4834677"/>
             <a:ext cx="1700784" cy="859536"/>
           </a:xfrm>
           <a:prstGeom prst="roundRect">
@@ -1600,7 +1824,7 @@
         </p:nvSpPr>
         <p:spPr>
           <a:xfrm>
-            <a:off x="2304288" y="4682272"/>
+            <a:off x="2304288" y="4834677"/>
             <a:ext cx="1627632" cy="859536"/>
           </a:xfrm>
           <a:prstGeom prst="rect">
@@ -1673,7 +1897,7 @@
         </p:nvSpPr>
         <p:spPr>
           <a:xfrm>
-            <a:off x="4946904" y="4481104"/>
+            <a:off x="4946904" y="4633509"/>
             <a:ext cx="0" cy="201168"/>
           </a:xfrm>
           <a:prstGeom prst="line">
@@ -1703,7 +1927,7 @@
         </p:nvSpPr>
         <p:spPr>
           <a:xfrm>
-            <a:off x="4096512" y="4682272"/>
+            <a:off x="4096512" y="4834677"/>
             <a:ext cx="1700784" cy="859536"/>
           </a:xfrm>
           <a:prstGeom prst="roundRect">
@@ -1732,7 +1956,7 @@
         </p:nvSpPr>
         <p:spPr>
           <a:xfrm>
-            <a:off x="4133088" y="4682272"/>
+            <a:off x="4133088" y="4834677"/>
             <a:ext cx="1627632" cy="859536"/>
           </a:xfrm>
           <a:prstGeom prst="rect">
@@ -1805,7 +2029,7 @@
         </p:nvSpPr>
         <p:spPr>
           <a:xfrm>
-            <a:off x="438912" y="5669824"/>
+            <a:off x="438912" y="5822229"/>
             <a:ext cx="5358384" cy="292608"/>
           </a:xfrm>
           <a:prstGeom prst="roundRect">
@@ -1834,7 +2058,7 @@
         </p:nvSpPr>
         <p:spPr>
           <a:xfrm>
-            <a:off x="438912" y="5669824"/>
+            <a:off x="438912" y="5822229"/>
             <a:ext cx="5358384" cy="292608"/>
           </a:xfrm>
           <a:prstGeom prst="rect">
@@ -1873,7 +2097,7 @@
         </p:nvSpPr>
         <p:spPr>
           <a:xfrm>
-            <a:off x="438912" y="5999008"/>
+            <a:off x="438912" y="6151413"/>
             <a:ext cx="5358384" cy="292608"/>
           </a:xfrm>
           <a:prstGeom prst="roundRect">
@@ -1902,7 +2126,7 @@
         </p:nvSpPr>
         <p:spPr>
           <a:xfrm>
-            <a:off x="438912" y="5999008"/>
+            <a:off x="438912" y="6151413"/>
             <a:ext cx="5358384" cy="292608"/>
           </a:xfrm>
           <a:prstGeom prst="rect">
@@ -1941,7 +2165,7 @@
         </p:nvSpPr>
         <p:spPr>
           <a:xfrm>
-            <a:off x="438912" y="6328192"/>
+            <a:off x="438912" y="6480597"/>
             <a:ext cx="5358384" cy="274320"/>
           </a:xfrm>
           <a:prstGeom prst="rect">
@@ -3057,7 +3281,7 @@
         <p:spPr>
           <a:xfrm>
             <a:off x="6144768" y="3054096"/>
-            <a:ext cx="5742432" cy="969264"/>
+            <a:ext cx="5742432" cy="1112890"/>
           </a:xfrm>
           <a:prstGeom prst="roundRect">
             <a:avLst>
@@ -3237,7 +3461,7 @@
         </p:blipFill>
         <p:spPr>
           <a:xfrm>
-            <a:off x="6144768" y="4096512"/>
+            <a:off x="6144768" y="4266847"/>
             <a:ext cx="5742432" cy="329184"/>
           </a:xfrm>
           <a:prstGeom prst="rect">
@@ -3253,7 +3477,7 @@
         </p:nvSpPr>
         <p:spPr>
           <a:xfrm>
-            <a:off x="6272784" y="4096512"/>
+            <a:off x="6272784" y="4266847"/>
             <a:ext cx="3158338" cy="329184"/>
           </a:xfrm>
           <a:prstGeom prst="rect">
@@ -3292,7 +3516,7 @@
         </p:nvSpPr>
         <p:spPr>
           <a:xfrm>
-            <a:off x="8154619" y="4096512"/>
+            <a:off x="8154619" y="4266847"/>
             <a:ext cx="3604565" cy="329184"/>
           </a:xfrm>
           <a:prstGeom prst="rect">
@@ -3327,7 +3551,7 @@
                 <a:latin typeface="Segoe UI" pitchFamily="34" charset="0"/>
                 <a:ea typeface="Segoe UI" pitchFamily="34" charset="-122"/>
                 <a:cs typeface="Segoe UI" pitchFamily="34" charset="-120"/>
-                <a:hlinkClick r:id="rId5">
+                <a:hlinkClick r:id="rId8">
                   <a:extLst>
                     <a:ext uri="{A12FA001-AC4F-418D-AE19-62706E023703}">
                       <ahyp:hlinkClr xmlns:ahyp="http://schemas.microsoft.com/office/drawing/2018/hyperlinkcolor" val="tx"/>
@@ -3372,13 +3596,13 @@
           <p:nvPr>
             <p:extLst>
               <p:ext uri="{D42A27DB-BD31-4B8C-83A1-F6EECF244321}">
-                <p14:modId xmlns:p14="http://schemas.microsoft.com/office/powerpoint/2010/main" val="1579011935"/>
+                <p14:modId xmlns:p14="http://schemas.microsoft.com/office/powerpoint/2010/main" val="1247097555"/>
               </p:ext>
             </p:extLst>
           </p:nvPr>
         </p:nvGraphicFramePr>
         <p:xfrm>
-          <a:off x="6144768" y="4443984"/>
+          <a:off x="6144768" y="4614319"/>
           <a:ext cx="5742432" cy="1600200"/>
         </p:xfrm>
         <a:graphic>
@@ -4433,7 +4657,7 @@
         </p:blipFill>
         <p:spPr>
           <a:xfrm>
-            <a:off x="6144768" y="6199632"/>
+            <a:off x="6144768" y="6369967"/>
             <a:ext cx="5742432" cy="329184"/>
           </a:xfrm>
           <a:prstGeom prst="rect">
@@ -4449,7 +4673,7 @@
         </p:nvSpPr>
         <p:spPr>
           <a:xfrm>
-            <a:off x="6272784" y="6199632"/>
+            <a:off x="6272784" y="6369967"/>
             <a:ext cx="4938492" cy="329184"/>
           </a:xfrm>
           <a:prstGeom prst="rect">
@@ -4488,7 +4712,7 @@
         </p:nvSpPr>
         <p:spPr>
           <a:xfrm>
-            <a:off x="8154619" y="6199632"/>
+            <a:off x="8154619" y="6369967"/>
             <a:ext cx="3604565" cy="329184"/>
           </a:xfrm>
           <a:prstGeom prst="rect">

</xml_diff>